<commit_message>
updated ppt, pdf and word files
</commit_message>
<xml_diff>
--- a/04/04_eloadas_https_tls_tanusitvanyok.pptx
+++ b/04/04_eloadas_https_tls_tanusitvanyok.pptx
@@ -213,7 +213,7 @@
           <a:p>
             <a:fld id="{4C482E4E-5CEC-44A9-BF2B-512FB3B5604F}" type="datetimeFigureOut">
               <a:rPr lang="en-US" smtClean="0"/>
-              <a:t>2/21/2026</a:t>
+              <a:t>3/7/2026</a:t>
             </a:fld>
             <a:endParaRPr lang="en-US"/>
           </a:p>
@@ -853,10 +853,6 @@
               <a:t>kulcscsere</a:t>
             </a:r>
             <a:r>
-              <a:rPr lang="en-US" dirty="0"/>
-              <a:t>.</a:t>
-            </a:r>
-            <a:r>
               <a:rPr lang="hu-HU" dirty="0"/>
               <a:t>, amely során </a:t>
             </a:r>
@@ -6808,7 +6804,7 @@
           <a:p>
             <a:r>
               <a:rPr lang="hu-HU" dirty="0"/>
-              <a:t>A TLS két rétegből áll: </a:t>
+              <a:t>A TLS két fő rétegből áll: </a:t>
             </a:r>
             <a:r>
               <a:rPr lang="hu-HU" dirty="0" err="1"/>
@@ -6840,7 +6836,31 @@
             </a:r>
             <a:r>
               <a:rPr lang="hu-HU" dirty="0"/>
-              <a:t>.</a:t>
+              <a:t>. A </a:t>
+            </a:r>
+            <a:r>
+              <a:rPr lang="hu-HU" dirty="0" err="1"/>
+              <a:t>Handshake</a:t>
+            </a:r>
+            <a:r>
+              <a:rPr lang="hu-HU" dirty="0"/>
+              <a:t> mellett helyezkedik el az </a:t>
+            </a:r>
+            <a:r>
+              <a:rPr lang="hu-HU" dirty="0" err="1"/>
+              <a:t>Alert</a:t>
+            </a:r>
+            <a:r>
+              <a:rPr lang="hu-HU" dirty="0"/>
+              <a:t> és a </a:t>
+            </a:r>
+            <a:r>
+              <a:rPr lang="hu-HU" dirty="0" err="1"/>
+              <a:t>ChangeCipherSpec</a:t>
+            </a:r>
+            <a:r>
+              <a:rPr lang="hu-HU" dirty="0"/>
+              <a:t> réteg is.</a:t>
             </a:r>
           </a:p>
           <a:p>
@@ -9232,7 +9252,7 @@
           <a:p>
             <a:fld id="{E80C50CD-E178-4744-9B35-B2F624D6C5E9}" type="datetimeFigureOut">
               <a:rPr lang="en-US" smtClean="0"/>
-              <a:t>2/21/2026</a:t>
+              <a:t>3/7/2026</a:t>
             </a:fld>
             <a:endParaRPr lang="en-US"/>
           </a:p>
@@ -9430,7 +9450,7 @@
           <a:p>
             <a:fld id="{E80C50CD-E178-4744-9B35-B2F624D6C5E9}" type="datetimeFigureOut">
               <a:rPr lang="en-US" smtClean="0"/>
-              <a:t>2/21/2026</a:t>
+              <a:t>3/7/2026</a:t>
             </a:fld>
             <a:endParaRPr lang="en-US"/>
           </a:p>
@@ -9638,7 +9658,7 @@
           <a:p>
             <a:fld id="{E80C50CD-E178-4744-9B35-B2F624D6C5E9}" type="datetimeFigureOut">
               <a:rPr lang="en-US" smtClean="0"/>
-              <a:t>2/21/2026</a:t>
+              <a:t>3/7/2026</a:t>
             </a:fld>
             <a:endParaRPr lang="en-US"/>
           </a:p>
@@ -9888,7 +9908,7 @@
           <a:p>
             <a:fld id="{E80C50CD-E178-4744-9B35-B2F624D6C5E9}" type="datetimeFigureOut">
               <a:rPr lang="en-US" smtClean="0"/>
-              <a:t>2/21/2026</a:t>
+              <a:t>3/7/2026</a:t>
             </a:fld>
             <a:endParaRPr lang="en-US"/>
           </a:p>
@@ -10167,7 +10187,7 @@
           <a:p>
             <a:fld id="{E80C50CD-E178-4744-9B35-B2F624D6C5E9}" type="datetimeFigureOut">
               <a:rPr lang="en-US" smtClean="0"/>
-              <a:t>2/21/2026</a:t>
+              <a:t>3/7/2026</a:t>
             </a:fld>
             <a:endParaRPr lang="en-US"/>
           </a:p>
@@ -10484,7 +10504,7 @@
           <a:p>
             <a:fld id="{E80C50CD-E178-4744-9B35-B2F624D6C5E9}" type="datetimeFigureOut">
               <a:rPr lang="en-US" smtClean="0"/>
-              <a:t>2/21/2026</a:t>
+              <a:t>3/7/2026</a:t>
             </a:fld>
             <a:endParaRPr lang="en-US"/>
           </a:p>
@@ -10900,7 +10920,7 @@
           <a:p>
             <a:fld id="{E80C50CD-E178-4744-9B35-B2F624D6C5E9}" type="datetimeFigureOut">
               <a:rPr lang="en-US" smtClean="0"/>
-              <a:t>2/21/2026</a:t>
+              <a:t>3/7/2026</a:t>
             </a:fld>
             <a:endParaRPr lang="en-US"/>
           </a:p>
@@ -11041,7 +11061,7 @@
           <a:p>
             <a:fld id="{E80C50CD-E178-4744-9B35-B2F624D6C5E9}" type="datetimeFigureOut">
               <a:rPr lang="en-US" smtClean="0"/>
-              <a:t>2/21/2026</a:t>
+              <a:t>3/7/2026</a:t>
             </a:fld>
             <a:endParaRPr lang="en-US"/>
           </a:p>
@@ -11154,7 +11174,7 @@
           <a:p>
             <a:fld id="{E80C50CD-E178-4744-9B35-B2F624D6C5E9}" type="datetimeFigureOut">
               <a:rPr lang="en-US" smtClean="0"/>
-              <a:t>2/21/2026</a:t>
+              <a:t>3/7/2026</a:t>
             </a:fld>
             <a:endParaRPr lang="en-US"/>
           </a:p>
@@ -11471,7 +11491,7 @@
           <a:p>
             <a:fld id="{E80C50CD-E178-4744-9B35-B2F624D6C5E9}" type="datetimeFigureOut">
               <a:rPr lang="en-US" smtClean="0"/>
-              <a:t>2/21/2026</a:t>
+              <a:t>3/7/2026</a:t>
             </a:fld>
             <a:endParaRPr lang="en-US"/>
           </a:p>
@@ -11763,7 +11783,7 @@
           <a:p>
             <a:fld id="{E80C50CD-E178-4744-9B35-B2F624D6C5E9}" type="datetimeFigureOut">
               <a:rPr lang="en-US" smtClean="0"/>
-              <a:t>2/21/2026</a:t>
+              <a:t>3/7/2026</a:t>
             </a:fld>
             <a:endParaRPr lang="en-US"/>
           </a:p>
@@ -12003,7 +12023,7 @@
             <a:fld id="{E80C50CD-E178-4744-9B35-B2F624D6C5E9}" type="datetimeFigureOut">
               <a:rPr lang="en-US" smtClean="0"/>
               <a:pPr/>
-              <a:t>2/21/2026</a:t>
+              <a:t>3/7/2026</a:t>
             </a:fld>
             <a:endParaRPr lang="en-US"/>
           </a:p>

</xml_diff>